<commit_message>
fix(presentation): Folie 4+5 Feinschliff, Footer vereinheitlicht, Build-Skripte
- Folie 4: Projektrahmen als groesserer Block (18pt, mehr Abstand)
- Folie 5: einheitliche quadratische Marker, gleichmaessige Abstaende
- Footer deckweit vereinheitlicht (navy Balken, weisser Text)
- Build- und QA-Skripte unter praesentation/ ergaenzt
</commit_message>
<xml_diff>
--- a/Praesentaion_Nguyen_Johannes.pptx
+++ b/Praesentaion_Nguyen_Johannes.pptx
@@ -5249,7 +5249,7 @@
             <a:r>
               <a:rPr sz="800" b="0" i="0">
                 <a:solidFill>
-                  <a:srgbClr val="6B7A90"/>
+                  <a:srgbClr val="FFFFFF"/>
                 </a:solidFill>
                 <a:latin typeface="Arial"/>
               </a:rPr>
@@ -5284,7 +5284,7 @@
             <a:r>
               <a:rPr sz="800" b="0" i="0">
                 <a:solidFill>
-                  <a:srgbClr val="6B7A90"/>
+                  <a:srgbClr val="FFFFFF"/>
                 </a:solidFill>
                 <a:latin typeface="Arial"/>
               </a:rPr>
@@ -6612,7 +6612,7 @@
             <a:r>
               <a:rPr sz="800" b="0" i="0">
                 <a:solidFill>
-                  <a:srgbClr val="6B7A90"/>
+                  <a:srgbClr val="FFFFFF"/>
                 </a:solidFill>
                 <a:latin typeface="Arial"/>
               </a:rPr>
@@ -6647,7 +6647,7 @@
             <a:r>
               <a:rPr sz="800" b="0" i="0">
                 <a:solidFill>
-                  <a:srgbClr val="6B7A90"/>
+                  <a:srgbClr val="FFFFFF"/>
                 </a:solidFill>
                 <a:latin typeface="Arial"/>
               </a:rPr>
@@ -8744,7 +8744,7 @@
             <a:avLst/>
           </a:prstGeom>
           <a:solidFill>
-            <a:srgbClr val="131325"/>
+            <a:srgbClr val="003F72"/>
           </a:solidFill>
           <a:ln>
             <a:noFill/>
@@ -8799,7 +8799,7 @@
             <a:r>
               <a:rPr sz="800" b="0">
                 <a:solidFill>
-                  <a:srgbClr val="6B7A90"/>
+                  <a:srgbClr val="FFFFFF"/>
                 </a:solidFill>
                 <a:latin typeface="Arial"/>
               </a:rPr>
@@ -8834,7 +8834,7 @@
             <a:r>
               <a:rPr sz="800" b="0">
                 <a:solidFill>
-                  <a:srgbClr val="6B7A90"/>
+                  <a:srgbClr val="FFFFFF"/>
                 </a:solidFill>
                 <a:latin typeface="Arial"/>
               </a:rPr>
@@ -11391,7 +11391,7 @@
             <a:r>
               <a:rPr sz="800" b="0" i="0">
                 <a:solidFill>
-                  <a:srgbClr val="6B7A90"/>
+                  <a:srgbClr val="FFFFFF"/>
                 </a:solidFill>
                 <a:latin typeface="Arial"/>
               </a:rPr>
@@ -11426,7 +11426,7 @@
             <a:r>
               <a:rPr sz="800" b="0" i="0">
                 <a:solidFill>
-                  <a:srgbClr val="6B7A90"/>
+                  <a:srgbClr val="FFFFFF"/>
                 </a:solidFill>
                 <a:latin typeface="Arial"/>
               </a:rPr>
@@ -12386,7 +12386,7 @@
             <a:r>
               <a:rPr sz="800" b="0" i="0">
                 <a:solidFill>
-                  <a:srgbClr val="6B7A90"/>
+                  <a:srgbClr val="FFFFFF"/>
                 </a:solidFill>
                 <a:latin typeface="Arial"/>
               </a:rPr>
@@ -12421,7 +12421,7 @@
             <a:r>
               <a:rPr sz="800" b="0" i="0">
                 <a:solidFill>
-                  <a:srgbClr val="6B7A90"/>
+                  <a:srgbClr val="FFFFFF"/>
                 </a:solidFill>
                 <a:latin typeface="Arial"/>
               </a:rPr>
@@ -13503,7 +13503,7 @@
             <a:r>
               <a:rPr sz="800" b="0" i="0">
                 <a:solidFill>
-                  <a:srgbClr val="6B7A90"/>
+                  <a:srgbClr val="FFFFFF"/>
                 </a:solidFill>
                 <a:latin typeface="Arial"/>
               </a:rPr>
@@ -13538,7 +13538,7 @@
             <a:r>
               <a:rPr sz="800" b="0" i="0">
                 <a:solidFill>
-                  <a:srgbClr val="6B7A90"/>
+                  <a:srgbClr val="FFFFFF"/>
                 </a:solidFill>
                 <a:latin typeface="Arial"/>
               </a:rPr>
@@ -15057,7 +15057,7 @@
             <a:r>
               <a:rPr sz="800" b="0" i="0">
                 <a:solidFill>
-                  <a:srgbClr val="6B7A90"/>
+                  <a:srgbClr val="FFFFFF"/>
                 </a:solidFill>
                 <a:latin typeface="Arial"/>
               </a:rPr>
@@ -15092,7 +15092,7 @@
             <a:r>
               <a:rPr sz="800" b="0" i="0">
                 <a:solidFill>
-                  <a:srgbClr val="6B7A90"/>
+                  <a:srgbClr val="FFFFFF"/>
                 </a:solidFill>
                 <a:latin typeface="Arial"/>
               </a:rPr>
@@ -16051,6 +16051,7 @@
           <a:ln>
             <a:noFill/>
           </a:ln>
+          <a:effectLst/>
         </p:spPr>
         <p:style>
           <a:lnRef idx="1">
@@ -16083,7 +16084,7 @@
         <p:spPr>
           <a:xfrm>
             <a:off x="0" y="936000"/>
-            <a:ext cx="12193200" cy="19050"/>
+            <a:ext cx="12193200" cy="18000"/>
           </a:xfrm>
           <a:prstGeom prst="rect">
             <a:avLst/>
@@ -16094,6 +16095,7 @@
           <a:ln>
             <a:noFill/>
           </a:ln>
+          <a:effectLst/>
         </p:spPr>
         <p:style>
           <a:lnRef idx="1">
@@ -16126,22 +16128,22 @@
         <p:spPr>
           <a:xfrm>
             <a:off x="360000" y="72000"/>
-            <a:ext cx="9673200" cy="540000"/>
-          </a:xfrm>
-          <a:prstGeom prst="rect">
-            <a:avLst/>
-          </a:prstGeom>
-          <a:noFill/>
-        </p:spPr>
-        <p:txBody>
-          <a:bodyPr wrap="square">
-            <a:spAutoFit/>
-          </a:bodyPr>
-          <a:lstStyle/>
-          <a:p>
-            <a:pPr algn="l"/>
-            <a:r>
-              <a:rPr sz="2400" b="1" i="0">
+            <a:ext cx="9493200" cy="522000"/>
+          </a:xfrm>
+          <a:prstGeom prst="rect">
+            <a:avLst/>
+          </a:prstGeom>
+          <a:noFill/>
+        </p:spPr>
+        <p:txBody>
+          <a:bodyPr wrap="square" anchor="t" tIns="7200" bIns="7200">
+            <a:spAutoFit/>
+          </a:bodyPr>
+          <a:lstStyle/>
+          <a:p>
+            <a:pPr algn="l"/>
+            <a:r>
+              <a:rPr sz="2300" b="1">
                 <a:solidFill>
                   <a:srgbClr val="FFFFFF"/>
                 </a:solidFill>
@@ -16160,23 +16162,23 @@
         </p:nvSpPr>
         <p:spPr>
           <a:xfrm>
-            <a:off x="360000" y="540000"/>
-            <a:ext cx="9673200" cy="360000"/>
-          </a:xfrm>
-          <a:prstGeom prst="rect">
-            <a:avLst/>
-          </a:prstGeom>
-          <a:noFill/>
-        </p:spPr>
-        <p:txBody>
-          <a:bodyPr wrap="square">
-            <a:spAutoFit/>
-          </a:bodyPr>
-          <a:lstStyle/>
-          <a:p>
-            <a:pPr algn="l"/>
-            <a:r>
-              <a:rPr sz="1300" b="0" i="0">
+            <a:off x="360000" y="576000"/>
+            <a:ext cx="9493200" cy="306000"/>
+          </a:xfrm>
+          <a:prstGeom prst="rect">
+            <a:avLst/>
+          </a:prstGeom>
+          <a:noFill/>
+        </p:spPr>
+        <p:txBody>
+          <a:bodyPr wrap="square" anchor="t" tIns="7200" bIns="7200">
+            <a:spAutoFit/>
+          </a:bodyPr>
+          <a:lstStyle/>
+          <a:p>
+            <a:pPr algn="l"/>
+            <a:r>
+              <a:rPr sz="1200" b="0">
                 <a:solidFill>
                   <a:srgbClr val="009ED9"/>
                 </a:solidFill>
@@ -16189,7 +16191,7 @@
       </p:sp>
       <p:pic>
         <p:nvPicPr>
-          <p:cNvPr id="6" name="Picture 5" descr="DKFZ_Logo-horiz_de_White_RGB_Avance.png"/>
+          <p:cNvPr id="6" name="Picture 5" descr="image.png"/>
           <p:cNvPicPr>
             <a:picLocks noChangeAspect="1"/>
           </p:cNvPicPr>
@@ -16203,7 +16205,7 @@
         </p:blipFill>
         <p:spPr>
           <a:xfrm>
-            <a:off x="9853200" y="108000"/>
+            <a:off x="9745200" y="108000"/>
             <a:ext cx="2232000" cy="409817"/>
           </a:xfrm>
           <a:prstGeom prst="rect">
@@ -16219,8 +16221,8 @@
         </p:nvSpPr>
         <p:spPr>
           <a:xfrm>
-            <a:off x="0" y="6588000"/>
-            <a:ext cx="12193200" cy="270000"/>
+            <a:off x="0" y="6606001"/>
+            <a:ext cx="12193200" cy="251999"/>
           </a:xfrm>
           <a:prstGeom prst="rect">
             <a:avLst/>
@@ -16231,6 +16233,7 @@
           <a:ln>
             <a:noFill/>
           </a:ln>
+          <a:effectLst/>
         </p:spPr>
         <p:style>
           <a:lnRef idx="1">
@@ -16262,25 +16265,25 @@
         </p:nvSpPr>
         <p:spPr>
           <a:xfrm>
-            <a:off x="360000" y="6624000"/>
-            <a:ext cx="10753200" cy="234000"/>
-          </a:xfrm>
-          <a:prstGeom prst="rect">
-            <a:avLst/>
-          </a:prstGeom>
-          <a:noFill/>
-        </p:spPr>
-        <p:txBody>
-          <a:bodyPr wrap="square">
-            <a:spAutoFit/>
-          </a:bodyPr>
-          <a:lstStyle/>
-          <a:p>
-            <a:pPr algn="l"/>
-            <a:r>
-              <a:rPr sz="800" b="0" i="0">
-                <a:solidFill>
-                  <a:srgbClr val="6B7A90"/>
+            <a:off x="360000" y="6642001"/>
+            <a:ext cx="10753200" cy="197999"/>
+          </a:xfrm>
+          <a:prstGeom prst="rect">
+            <a:avLst/>
+          </a:prstGeom>
+          <a:noFill/>
+        </p:spPr>
+        <p:txBody>
+          <a:bodyPr wrap="square" anchor="t" tIns="7200" bIns="7200">
+            <a:spAutoFit/>
+          </a:bodyPr>
+          <a:lstStyle/>
+          <a:p>
+            <a:pPr algn="l"/>
+            <a:r>
+              <a:rPr sz="800" b="0">
+                <a:solidFill>
+                  <a:srgbClr val="FFFFFF"/>
                 </a:solidFill>
                 <a:latin typeface="Arial"/>
               </a:rPr>
@@ -16297,25 +16300,25 @@
         </p:nvSpPr>
         <p:spPr>
           <a:xfrm>
-            <a:off x="10933200" y="6624000"/>
-            <a:ext cx="1152000" cy="234000"/>
-          </a:xfrm>
-          <a:prstGeom prst="rect">
-            <a:avLst/>
-          </a:prstGeom>
-          <a:noFill/>
-        </p:spPr>
-        <p:txBody>
-          <a:bodyPr wrap="square">
+            <a:off x="10933200" y="6642001"/>
+            <a:ext cx="1152000" cy="197999"/>
+          </a:xfrm>
+          <a:prstGeom prst="rect">
+            <a:avLst/>
+          </a:prstGeom>
+          <a:noFill/>
+        </p:spPr>
+        <p:txBody>
+          <a:bodyPr wrap="square" anchor="t" tIns="7200" bIns="7200">
             <a:spAutoFit/>
           </a:bodyPr>
           <a:lstStyle/>
           <a:p>
             <a:pPr algn="r"/>
             <a:r>
-              <a:rPr sz="800" b="0" i="0">
-                <a:solidFill>
-                  <a:srgbClr val="6B7A90"/>
+              <a:rPr sz="800" b="0">
+                <a:solidFill>
+                  <a:srgbClr val="FFFFFF"/>
                 </a:solidFill>
                 <a:latin typeface="Arial"/>
               </a:rPr>
@@ -16332,8 +16335,8 @@
         </p:nvSpPr>
         <p:spPr>
           <a:xfrm>
-            <a:off x="360000" y="1152000"/>
-            <a:ext cx="5580000" cy="259200"/>
+            <a:off x="360000" y="1116000"/>
+            <a:ext cx="5646600" cy="259200"/>
           </a:xfrm>
           <a:prstGeom prst="rect">
             <a:avLst/>
@@ -16344,6 +16347,7 @@
           <a:ln>
             <a:noFill/>
           </a:ln>
+          <a:effectLst/>
         </p:spPr>
         <p:style>
           <a:lnRef idx="1">
@@ -16375,23 +16379,23 @@
         </p:nvSpPr>
         <p:spPr>
           <a:xfrm>
-            <a:off x="468000" y="1180800"/>
-            <a:ext cx="5436000" cy="223200"/>
-          </a:xfrm>
-          <a:prstGeom prst="rect">
-            <a:avLst/>
-          </a:prstGeom>
-          <a:noFill/>
-        </p:spPr>
-        <p:txBody>
-          <a:bodyPr wrap="square">
-            <a:spAutoFit/>
-          </a:bodyPr>
-          <a:lstStyle/>
-          <a:p>
-            <a:pPr algn="l"/>
-            <a:r>
-              <a:rPr sz="1200" b="1" i="0">
+            <a:off x="468000" y="1116000"/>
+            <a:ext cx="5502600" cy="259200"/>
+          </a:xfrm>
+          <a:prstGeom prst="rect">
+            <a:avLst/>
+          </a:prstGeom>
+          <a:noFill/>
+        </p:spPr>
+        <p:txBody>
+          <a:bodyPr wrap="square" anchor="ctr" tIns="7200" bIns="7200">
+            <a:spAutoFit/>
+          </a:bodyPr>
+          <a:lstStyle/>
+          <a:p>
+            <a:pPr algn="l"/>
+            <a:r>
+              <a:rPr sz="1300" b="1">
                 <a:solidFill>
                   <a:srgbClr val="FFFFFF"/>
                 </a:solidFill>
@@ -16410,8 +16414,8 @@
         </p:nvSpPr>
         <p:spPr>
           <a:xfrm>
-            <a:off x="360000" y="1411200"/>
-            <a:ext cx="5580000" cy="2332800"/>
+            <a:off x="360000" y="1375200"/>
+            <a:ext cx="5646600" cy="2044800"/>
           </a:xfrm>
           <a:prstGeom prst="rect">
             <a:avLst/>
@@ -16419,11 +16423,12 @@
           <a:solidFill>
             <a:srgbClr val="F4F7FA"/>
           </a:solidFill>
-          <a:ln w="9525">
+          <a:ln w="6350">
             <a:solidFill>
-              <a:srgbClr val="E8EDF3"/>
+              <a:srgbClr val="009ED9"/>
             </a:solidFill>
           </a:ln>
+          <a:effectLst/>
         </p:spPr>
         <p:style>
           <a:lnRef idx="1">
@@ -16455,23 +16460,23 @@
         </p:nvSpPr>
         <p:spPr>
           <a:xfrm>
-            <a:off x="504000" y="1483200"/>
-            <a:ext cx="5364000" cy="592200"/>
-          </a:xfrm>
-          <a:prstGeom prst="rect">
-            <a:avLst/>
-          </a:prstGeom>
-          <a:noFill/>
-        </p:spPr>
-        <p:txBody>
-          <a:bodyPr wrap="square">
-            <a:spAutoFit/>
-          </a:bodyPr>
-          <a:lstStyle/>
-          <a:p>
-            <a:pPr algn="l"/>
-            <a:r>
-              <a:rPr sz="1400" b="0" i="0">
+            <a:off x="485999" y="1429200"/>
+            <a:ext cx="5430600" cy="484200"/>
+          </a:xfrm>
+          <a:prstGeom prst="rect">
+            <a:avLst/>
+          </a:prstGeom>
+          <a:noFill/>
+        </p:spPr>
+        <p:txBody>
+          <a:bodyPr wrap="square" anchor="ctr" tIns="7200" bIns="7200">
+            <a:spAutoFit/>
+          </a:bodyPr>
+          <a:lstStyle/>
+          <a:p>
+            <a:pPr algn="l"/>
+            <a:r>
+              <a:rPr sz="1400" b="0">
                 <a:solidFill>
                   <a:srgbClr val="1C1C2E"/>
                 </a:solidFill>
@@ -16490,23 +16495,23 @@
         </p:nvSpPr>
         <p:spPr>
           <a:xfrm>
-            <a:off x="504000" y="2039400"/>
-            <a:ext cx="5364000" cy="592200"/>
-          </a:xfrm>
-          <a:prstGeom prst="rect">
-            <a:avLst/>
-          </a:prstGeom>
-          <a:noFill/>
-        </p:spPr>
-        <p:txBody>
-          <a:bodyPr wrap="square">
-            <a:spAutoFit/>
-          </a:bodyPr>
-          <a:lstStyle/>
-          <a:p>
-            <a:pPr algn="l"/>
-            <a:r>
-              <a:rPr sz="1400" b="0" i="0">
+            <a:off x="485999" y="1913400"/>
+            <a:ext cx="5430600" cy="484200"/>
+          </a:xfrm>
+          <a:prstGeom prst="rect">
+            <a:avLst/>
+          </a:prstGeom>
+          <a:noFill/>
+        </p:spPr>
+        <p:txBody>
+          <a:bodyPr wrap="square" anchor="ctr" tIns="7200" bIns="7200">
+            <a:spAutoFit/>
+          </a:bodyPr>
+          <a:lstStyle/>
+          <a:p>
+            <a:pPr algn="l"/>
+            <a:r>
+              <a:rPr sz="1400" b="0">
                 <a:solidFill>
                   <a:srgbClr val="1C1C2E"/>
                 </a:solidFill>
@@ -16525,23 +16530,23 @@
         </p:nvSpPr>
         <p:spPr>
           <a:xfrm>
-            <a:off x="504000" y="2595600"/>
-            <a:ext cx="5364000" cy="592200"/>
-          </a:xfrm>
-          <a:prstGeom prst="rect">
-            <a:avLst/>
-          </a:prstGeom>
-          <a:noFill/>
-        </p:spPr>
-        <p:txBody>
-          <a:bodyPr wrap="square">
-            <a:spAutoFit/>
-          </a:bodyPr>
-          <a:lstStyle/>
-          <a:p>
-            <a:pPr algn="l"/>
-            <a:r>
-              <a:rPr sz="1400" b="0" i="0">
+            <a:off x="485999" y="2397600"/>
+            <a:ext cx="5430600" cy="484200"/>
+          </a:xfrm>
+          <a:prstGeom prst="rect">
+            <a:avLst/>
+          </a:prstGeom>
+          <a:noFill/>
+        </p:spPr>
+        <p:txBody>
+          <a:bodyPr wrap="square" anchor="ctr" tIns="7200" bIns="7200">
+            <a:spAutoFit/>
+          </a:bodyPr>
+          <a:lstStyle/>
+          <a:p>
+            <a:pPr algn="l"/>
+            <a:r>
+              <a:rPr sz="1400" b="0">
                 <a:solidFill>
                   <a:srgbClr val="1C1C2E"/>
                 </a:solidFill>
@@ -16560,29 +16565,29 @@
         </p:nvSpPr>
         <p:spPr>
           <a:xfrm>
-            <a:off x="504000" y="3151800"/>
-            <a:ext cx="5364000" cy="592200"/>
-          </a:xfrm>
-          <a:prstGeom prst="rect">
-            <a:avLst/>
-          </a:prstGeom>
-          <a:noFill/>
-        </p:spPr>
-        <p:txBody>
-          <a:bodyPr wrap="square">
-            <a:spAutoFit/>
-          </a:bodyPr>
-          <a:lstStyle/>
-          <a:p>
-            <a:pPr algn="l"/>
-            <a:r>
-              <a:rPr sz="1400" b="0" i="0">
+            <a:off x="485999" y="2881800"/>
+            <a:ext cx="5430600" cy="484200"/>
+          </a:xfrm>
+          <a:prstGeom prst="rect">
+            <a:avLst/>
+          </a:prstGeom>
+          <a:noFill/>
+        </p:spPr>
+        <p:txBody>
+          <a:bodyPr wrap="square" anchor="ctr" tIns="7200" bIns="7200">
+            <a:spAutoFit/>
+          </a:bodyPr>
+          <a:lstStyle/>
+          <a:p>
+            <a:pPr algn="l"/>
+            <a:r>
+              <a:rPr sz="1400" b="0">
                 <a:solidFill>
                   <a:srgbClr val="1C1C2E"/>
                 </a:solidFill>
                 <a:latin typeface="Arial"/>
               </a:rPr>
-              <a:t>▸  Betreibt komplexe IT-Infrastruktur für genomische Daten</a:t>
+              <a:t>▸  Komplexe IT-Infrastruktur für genomische Daten</a:t>
             </a:r>
           </a:p>
         </p:txBody>
@@ -16595,8 +16600,8 @@
         </p:nvSpPr>
         <p:spPr>
           <a:xfrm>
-            <a:off x="5893200" y="1152000"/>
-            <a:ext cx="5940000" cy="259200"/>
+            <a:off x="6186600" y="1116000"/>
+            <a:ext cx="5646600" cy="259200"/>
           </a:xfrm>
           <a:prstGeom prst="rect">
             <a:avLst/>
@@ -16607,6 +16612,7 @@
           <a:ln>
             <a:noFill/>
           </a:ln>
+          <a:effectLst/>
         </p:spPr>
         <p:style>
           <a:lnRef idx="1">
@@ -16638,23 +16644,23 @@
         </p:nvSpPr>
         <p:spPr>
           <a:xfrm>
-            <a:off x="6001200" y="1180800"/>
-            <a:ext cx="5796000" cy="223200"/>
-          </a:xfrm>
-          <a:prstGeom prst="rect">
-            <a:avLst/>
-          </a:prstGeom>
-          <a:noFill/>
-        </p:spPr>
-        <p:txBody>
-          <a:bodyPr wrap="square">
-            <a:spAutoFit/>
-          </a:bodyPr>
-          <a:lstStyle/>
-          <a:p>
-            <a:pPr algn="l"/>
-            <a:r>
-              <a:rPr sz="1200" b="1" i="0">
+            <a:off x="6294600" y="1116000"/>
+            <a:ext cx="5502600" cy="259200"/>
+          </a:xfrm>
+          <a:prstGeom prst="rect">
+            <a:avLst/>
+          </a:prstGeom>
+          <a:noFill/>
+        </p:spPr>
+        <p:txBody>
+          <a:bodyPr wrap="square" anchor="ctr" tIns="7200" bIns="7200">
+            <a:spAutoFit/>
+          </a:bodyPr>
+          <a:lstStyle/>
+          <a:p>
+            <a:pPr algn="l"/>
+            <a:r>
+              <a:rPr sz="1300" b="1">
                 <a:solidFill>
                   <a:srgbClr val="FFFFFF"/>
                 </a:solidFill>
@@ -16673,8 +16679,8 @@
         </p:nvSpPr>
         <p:spPr>
           <a:xfrm>
-            <a:off x="5893200" y="1411200"/>
-            <a:ext cx="5940000" cy="2332800"/>
+            <a:off x="6186600" y="1375200"/>
+            <a:ext cx="5646600" cy="2044800"/>
           </a:xfrm>
           <a:prstGeom prst="rect">
             <a:avLst/>
@@ -16682,11 +16688,12 @@
           <a:solidFill>
             <a:srgbClr val="F4F7FA"/>
           </a:solidFill>
-          <a:ln w="9525">
+          <a:ln w="6350">
             <a:solidFill>
-              <a:srgbClr val="E8EDF3"/>
+              <a:srgbClr val="009ED9"/>
             </a:solidFill>
           </a:ln>
+          <a:effectLst/>
         </p:spPr>
         <p:style>
           <a:lnRef idx="1">
@@ -16718,23 +16725,23 @@
         </p:nvSpPr>
         <p:spPr>
           <a:xfrm>
-            <a:off x="6037200" y="1483200"/>
-            <a:ext cx="5724000" cy="592200"/>
-          </a:xfrm>
-          <a:prstGeom prst="rect">
-            <a:avLst/>
-          </a:prstGeom>
-          <a:noFill/>
-        </p:spPr>
-        <p:txBody>
-          <a:bodyPr wrap="square">
-            <a:spAutoFit/>
-          </a:bodyPr>
-          <a:lstStyle/>
-          <a:p>
-            <a:pPr algn="l"/>
-            <a:r>
-              <a:rPr sz="1400" b="0" i="0">
+            <a:off x="6312599" y="1429200"/>
+            <a:ext cx="5430600" cy="484200"/>
+          </a:xfrm>
+          <a:prstGeom prst="rect">
+            <a:avLst/>
+          </a:prstGeom>
+          <a:noFill/>
+        </p:spPr>
+        <p:txBody>
+          <a:bodyPr wrap="square" anchor="ctr" tIns="7200" bIns="7200">
+            <a:spAutoFit/>
+          </a:bodyPr>
+          <a:lstStyle/>
+          <a:p>
+            <a:pPr algn="l"/>
+            <a:r>
+              <a:rPr sz="1400" b="0">
                 <a:solidFill>
                   <a:srgbClr val="1C1C2E"/>
                 </a:solidFill>
@@ -16753,23 +16760,23 @@
         </p:nvSpPr>
         <p:spPr>
           <a:xfrm>
-            <a:off x="6037200" y="2039400"/>
-            <a:ext cx="5724000" cy="592200"/>
-          </a:xfrm>
-          <a:prstGeom prst="rect">
-            <a:avLst/>
-          </a:prstGeom>
-          <a:noFill/>
-        </p:spPr>
-        <p:txBody>
-          <a:bodyPr wrap="square">
-            <a:spAutoFit/>
-          </a:bodyPr>
-          <a:lstStyle/>
-          <a:p>
-            <a:pPr algn="l"/>
-            <a:r>
-              <a:rPr sz="1400" b="0" i="0">
+            <a:off x="6312599" y="1913400"/>
+            <a:ext cx="5430600" cy="484200"/>
+          </a:xfrm>
+          <a:prstGeom prst="rect">
+            <a:avLst/>
+          </a:prstGeom>
+          <a:noFill/>
+        </p:spPr>
+        <p:txBody>
+          <a:bodyPr wrap="square" anchor="ctr" tIns="7200" bIns="7200">
+            <a:spAutoFit/>
+          </a:bodyPr>
+          <a:lstStyle/>
+          <a:p>
+            <a:pPr algn="l"/>
+            <a:r>
+              <a:rPr sz="1400" b="0">
                 <a:solidFill>
                   <a:srgbClr val="1C1C2E"/>
                 </a:solidFill>
@@ -16788,23 +16795,23 @@
         </p:nvSpPr>
         <p:spPr>
           <a:xfrm>
-            <a:off x="6037200" y="2595600"/>
-            <a:ext cx="5724000" cy="592200"/>
-          </a:xfrm>
-          <a:prstGeom prst="rect">
-            <a:avLst/>
-          </a:prstGeom>
-          <a:noFill/>
-        </p:spPr>
-        <p:txBody>
-          <a:bodyPr wrap="square">
-            <a:spAutoFit/>
-          </a:bodyPr>
-          <a:lstStyle/>
-          <a:p>
-            <a:pPr algn="l"/>
-            <a:r>
-              <a:rPr sz="1400" b="0" i="0">
+            <a:off x="6312599" y="2397600"/>
+            <a:ext cx="5430600" cy="484200"/>
+          </a:xfrm>
+          <a:prstGeom prst="rect">
+            <a:avLst/>
+          </a:prstGeom>
+          <a:noFill/>
+        </p:spPr>
+        <p:txBody>
+          <a:bodyPr wrap="square" anchor="ctr" tIns="7200" bIns="7200">
+            <a:spAutoFit/>
+          </a:bodyPr>
+          <a:lstStyle/>
+          <a:p>
+            <a:pPr algn="l"/>
+            <a:r>
+              <a:rPr sz="1400" b="0">
                 <a:solidFill>
                   <a:srgbClr val="1C1C2E"/>
                 </a:solidFill>
@@ -16823,23 +16830,23 @@
         </p:nvSpPr>
         <p:spPr>
           <a:xfrm>
-            <a:off x="6037200" y="3151800"/>
-            <a:ext cx="5724000" cy="592200"/>
-          </a:xfrm>
-          <a:prstGeom prst="rect">
-            <a:avLst/>
-          </a:prstGeom>
-          <a:noFill/>
-        </p:spPr>
-        <p:txBody>
-          <a:bodyPr wrap="square">
-            <a:spAutoFit/>
-          </a:bodyPr>
-          <a:lstStyle/>
-          <a:p>
-            <a:pPr algn="l"/>
-            <a:r>
-              <a:rPr sz="1400" b="0" i="0">
+            <a:off x="6312599" y="2881800"/>
+            <a:ext cx="5430600" cy="484200"/>
+          </a:xfrm>
+          <a:prstGeom prst="rect">
+            <a:avLst/>
+          </a:prstGeom>
+          <a:noFill/>
+        </p:spPr>
+        <p:txBody>
+          <a:bodyPr wrap="square" anchor="ctr" tIns="7200" bIns="7200">
+            <a:spAutoFit/>
+          </a:bodyPr>
+          <a:lstStyle/>
+          <a:p>
+            <a:pPr algn="l"/>
+            <a:r>
+              <a:rPr sz="1400" b="0">
                 <a:solidFill>
                   <a:srgbClr val="1C1C2E"/>
                 </a:solidFill>
@@ -16852,134 +16859,259 @@
       </p:sp>
       <p:sp>
         <p:nvSpPr>
-          <p:cNvPr id="24" name="TextBox 23"/>
-          <p:cNvSpPr txBox="1"/>
-          <p:nvPr/>
-        </p:nvSpPr>
-        <p:spPr>
-          <a:xfrm>
-            <a:off x="360000" y="3852000"/>
-            <a:ext cx="1620000" cy="234000"/>
-          </a:xfrm>
-          <a:prstGeom prst="rect">
-            <a:avLst/>
-          </a:prstGeom>
-          <a:noFill/>
-        </p:spPr>
-        <p:txBody>
-          <a:bodyPr wrap="square">
-            <a:spAutoFit/>
-          </a:bodyPr>
-          <a:lstStyle/>
-          <a:p>
-            <a:pPr algn="l"/>
-            <a:r>
-              <a:rPr sz="1300" b="1" i="0">
+          <p:cNvPr id="24" name="Rectangle 23"/>
+          <p:cNvSpPr/>
+          <p:nvPr/>
+        </p:nvSpPr>
+        <p:spPr>
+          <a:xfrm>
+            <a:off x="360000" y="3671999"/>
+            <a:ext cx="11473200" cy="288000"/>
+          </a:xfrm>
+          <a:prstGeom prst="rect">
+            <a:avLst/>
+          </a:prstGeom>
+          <a:solidFill>
+            <a:srgbClr val="003F72"/>
+          </a:solidFill>
+          <a:ln>
+            <a:noFill/>
+          </a:ln>
+          <a:effectLst/>
+        </p:spPr>
+        <p:style>
+          <a:lnRef idx="1">
+            <a:schemeClr val="accent1"/>
+          </a:lnRef>
+          <a:fillRef idx="3">
+            <a:schemeClr val="accent1"/>
+          </a:fillRef>
+          <a:effectRef idx="2">
+            <a:schemeClr val="accent1"/>
+          </a:effectRef>
+          <a:fontRef idx="minor">
+            <a:schemeClr val="lt1"/>
+          </a:fontRef>
+        </p:style>
+        <p:txBody>
+          <a:bodyPr rtlCol="0" anchor="ctr"/>
+          <a:lstStyle/>
+          <a:p>
+            <a:pPr algn="ctr"/>
+          </a:p>
+        </p:txBody>
+      </p:sp>
+      <p:sp>
+        <p:nvSpPr>
+          <p:cNvPr id="25" name="TextBox 24"/>
+          <p:cNvSpPr txBox="1"/>
+          <p:nvPr/>
+        </p:nvSpPr>
+        <p:spPr>
+          <a:xfrm>
+            <a:off x="468000" y="3671999"/>
+            <a:ext cx="11329200" cy="288000"/>
+          </a:xfrm>
+          <a:prstGeom prst="rect">
+            <a:avLst/>
+          </a:prstGeom>
+          <a:noFill/>
+        </p:spPr>
+        <p:txBody>
+          <a:bodyPr wrap="square" anchor="ctr" tIns="7200" bIns="7200">
+            <a:spAutoFit/>
+          </a:bodyPr>
+          <a:lstStyle/>
+          <a:p>
+            <a:pPr algn="l"/>
+            <a:r>
+              <a:rPr sz="1500" b="1">
+                <a:solidFill>
+                  <a:srgbClr val="FFFFFF"/>
+                </a:solidFill>
+                <a:latin typeface="Arial"/>
+              </a:rPr>
+              <a:t>Projektrahmen</a:t>
+            </a:r>
+          </a:p>
+        </p:txBody>
+      </p:sp>
+      <p:sp>
+        <p:nvSpPr>
+          <p:cNvPr id="26" name="Rectangle 25"/>
+          <p:cNvSpPr/>
+          <p:nvPr/>
+        </p:nvSpPr>
+        <p:spPr>
+          <a:xfrm>
+            <a:off x="360000" y="3959999"/>
+            <a:ext cx="11473200" cy="1727999"/>
+          </a:xfrm>
+          <a:prstGeom prst="rect">
+            <a:avLst/>
+          </a:prstGeom>
+          <a:solidFill>
+            <a:srgbClr val="F4F7FA"/>
+          </a:solidFill>
+          <a:ln w="6350">
+            <a:solidFill>
+              <a:srgbClr val="009ED9"/>
+            </a:solidFill>
+          </a:ln>
+          <a:effectLst/>
+        </p:spPr>
+        <p:style>
+          <a:lnRef idx="1">
+            <a:schemeClr val="accent1"/>
+          </a:lnRef>
+          <a:fillRef idx="3">
+            <a:schemeClr val="accent1"/>
+          </a:fillRef>
+          <a:effectRef idx="2">
+            <a:schemeClr val="accent1"/>
+          </a:effectRef>
+          <a:fontRef idx="minor">
+            <a:schemeClr val="lt1"/>
+          </a:fontRef>
+        </p:style>
+        <p:txBody>
+          <a:bodyPr rtlCol="0" anchor="ctr"/>
+          <a:lstStyle/>
+          <a:p>
+            <a:pPr algn="ctr"/>
+          </a:p>
+        </p:txBody>
+      </p:sp>
+      <p:sp>
+        <p:nvSpPr>
+          <p:cNvPr id="27" name="TextBox 26"/>
+          <p:cNvSpPr txBox="1"/>
+          <p:nvPr/>
+        </p:nvSpPr>
+        <p:spPr>
+          <a:xfrm>
+            <a:off x="576000" y="3959999"/>
+            <a:ext cx="2520000" cy="575999"/>
+          </a:xfrm>
+          <a:prstGeom prst="rect">
+            <a:avLst/>
+          </a:prstGeom>
+          <a:noFill/>
+        </p:spPr>
+        <p:txBody>
+          <a:bodyPr wrap="square" anchor="ctr" tIns="7200" bIns="7200">
+            <a:spAutoFit/>
+          </a:bodyPr>
+          <a:lstStyle/>
+          <a:p>
+            <a:pPr algn="l"/>
+            <a:r>
+              <a:rPr sz="1800" b="1">
                 <a:solidFill>
                   <a:srgbClr val="003F72"/>
                 </a:solidFill>
                 <a:latin typeface="Arial"/>
               </a:rPr>
-              <a:t>Projektart:</a:t>
-            </a:r>
-          </a:p>
-        </p:txBody>
-      </p:sp>
-      <p:sp>
-        <p:nvSpPr>
-          <p:cNvPr id="25" name="TextBox 24"/>
-          <p:cNvSpPr txBox="1"/>
-          <p:nvPr/>
-        </p:nvSpPr>
-        <p:spPr>
-          <a:xfrm>
-            <a:off x="2015999" y="3852000"/>
-            <a:ext cx="9745200" cy="234000"/>
-          </a:xfrm>
-          <a:prstGeom prst="rect">
-            <a:avLst/>
-          </a:prstGeom>
-          <a:noFill/>
-        </p:spPr>
-        <p:txBody>
-          <a:bodyPr wrap="square">
-            <a:spAutoFit/>
-          </a:bodyPr>
-          <a:lstStyle/>
-          <a:p>
-            <a:pPr algn="l"/>
-            <a:r>
-              <a:rPr sz="1300" b="0" i="0">
+              <a:t>Projektart</a:t>
+            </a:r>
+          </a:p>
+        </p:txBody>
+      </p:sp>
+      <p:sp>
+        <p:nvSpPr>
+          <p:cNvPr id="28" name="TextBox 27"/>
+          <p:cNvSpPr txBox="1"/>
+          <p:nvPr/>
+        </p:nvSpPr>
+        <p:spPr>
+          <a:xfrm>
+            <a:off x="3240000" y="3959999"/>
+            <a:ext cx="8449200" cy="575999"/>
+          </a:xfrm>
+          <a:prstGeom prst="rect">
+            <a:avLst/>
+          </a:prstGeom>
+          <a:noFill/>
+        </p:spPr>
+        <p:txBody>
+          <a:bodyPr wrap="square" anchor="ctr" tIns="7200" bIns="7200">
+            <a:spAutoFit/>
+          </a:bodyPr>
+          <a:lstStyle/>
+          <a:p>
+            <a:pPr algn="l"/>
+            <a:r>
+              <a:rPr sz="1800" b="0">
                 <a:solidFill>
                   <a:srgbClr val="1C1C2E"/>
                 </a:solidFill>
                 <a:latin typeface="Arial"/>
               </a:rPr>
-              <a:t>Internes Projekt: Auftraggeber = Auftragnehmer (DKFZ)</a:t>
-            </a:r>
-          </a:p>
-        </p:txBody>
-      </p:sp>
-      <p:sp>
-        <p:nvSpPr>
-          <p:cNvPr id="26" name="TextBox 25"/>
-          <p:cNvSpPr txBox="1"/>
-          <p:nvPr/>
-        </p:nvSpPr>
-        <p:spPr>
-          <a:xfrm>
-            <a:off x="360000" y="4111200"/>
-            <a:ext cx="1620000" cy="234000"/>
-          </a:xfrm>
-          <a:prstGeom prst="rect">
-            <a:avLst/>
-          </a:prstGeom>
-          <a:noFill/>
-        </p:spPr>
-        <p:txBody>
-          <a:bodyPr wrap="square">
-            <a:spAutoFit/>
-          </a:bodyPr>
-          <a:lstStyle/>
-          <a:p>
-            <a:pPr algn="l"/>
-            <a:r>
-              <a:rPr sz="1300" b="1" i="0">
+              <a:t>Internes Projekt, Auftraggeber = Auftragnehmer (DKFZ)</a:t>
+            </a:r>
+          </a:p>
+        </p:txBody>
+      </p:sp>
+      <p:sp>
+        <p:nvSpPr>
+          <p:cNvPr id="29" name="TextBox 28"/>
+          <p:cNvSpPr txBox="1"/>
+          <p:nvPr/>
+        </p:nvSpPr>
+        <p:spPr>
+          <a:xfrm>
+            <a:off x="576000" y="4535998"/>
+            <a:ext cx="2520000" cy="575999"/>
+          </a:xfrm>
+          <a:prstGeom prst="rect">
+            <a:avLst/>
+          </a:prstGeom>
+          <a:noFill/>
+        </p:spPr>
+        <p:txBody>
+          <a:bodyPr wrap="square" anchor="ctr" tIns="7200" bIns="7200">
+            <a:spAutoFit/>
+          </a:bodyPr>
+          <a:lstStyle/>
+          <a:p>
+            <a:pPr algn="l"/>
+            <a:r>
+              <a:rPr sz="1800" b="1">
                 <a:solidFill>
                   <a:srgbClr val="003F72"/>
                 </a:solidFill>
                 <a:latin typeface="Arial"/>
               </a:rPr>
-              <a:t>Ausbildungsberuf:</a:t>
-            </a:r>
-          </a:p>
-        </p:txBody>
-      </p:sp>
-      <p:sp>
-        <p:nvSpPr>
-          <p:cNvPr id="27" name="TextBox 26"/>
-          <p:cNvSpPr txBox="1"/>
-          <p:nvPr/>
-        </p:nvSpPr>
-        <p:spPr>
-          <a:xfrm>
-            <a:off x="2015999" y="4111200"/>
-            <a:ext cx="9745200" cy="234000"/>
-          </a:xfrm>
-          <a:prstGeom prst="rect">
-            <a:avLst/>
-          </a:prstGeom>
-          <a:noFill/>
-        </p:spPr>
-        <p:txBody>
-          <a:bodyPr wrap="square">
-            <a:spAutoFit/>
-          </a:bodyPr>
-          <a:lstStyle/>
-          <a:p>
-            <a:pPr algn="l"/>
-            <a:r>
-              <a:rPr sz="1300" b="0" i="0">
+              <a:t>Ausbildungsberuf</a:t>
+            </a:r>
+          </a:p>
+        </p:txBody>
+      </p:sp>
+      <p:sp>
+        <p:nvSpPr>
+          <p:cNvPr id="30" name="TextBox 29"/>
+          <p:cNvSpPr txBox="1"/>
+          <p:nvPr/>
+        </p:nvSpPr>
+        <p:spPr>
+          <a:xfrm>
+            <a:off x="3240000" y="4535998"/>
+            <a:ext cx="8449200" cy="575999"/>
+          </a:xfrm>
+          <a:prstGeom prst="rect">
+            <a:avLst/>
+          </a:prstGeom>
+          <a:noFill/>
+        </p:spPr>
+        <p:txBody>
+          <a:bodyPr wrap="square" anchor="ctr" tIns="7200" bIns="7200">
+            <a:spAutoFit/>
+          </a:bodyPr>
+          <a:lstStyle/>
+          <a:p>
+            <a:pPr algn="l"/>
+            <a:r>
+              <a:rPr sz="1800" b="0">
                 <a:solidFill>
                   <a:srgbClr val="1C1C2E"/>
                 </a:solidFill>
@@ -16992,70 +17124,70 @@
       </p:sp>
       <p:sp>
         <p:nvSpPr>
-          <p:cNvPr id="28" name="TextBox 27"/>
-          <p:cNvSpPr txBox="1"/>
-          <p:nvPr/>
-        </p:nvSpPr>
-        <p:spPr>
-          <a:xfrm>
-            <a:off x="360000" y="4370400"/>
-            <a:ext cx="1620000" cy="234000"/>
-          </a:xfrm>
-          <a:prstGeom prst="rect">
-            <a:avLst/>
-          </a:prstGeom>
-          <a:noFill/>
-        </p:spPr>
-        <p:txBody>
-          <a:bodyPr wrap="square">
-            <a:spAutoFit/>
-          </a:bodyPr>
-          <a:lstStyle/>
-          <a:p>
-            <a:pPr algn="l"/>
-            <a:r>
-              <a:rPr sz="1300" b="1" i="0">
+          <p:cNvPr id="31" name="TextBox 30"/>
+          <p:cNvSpPr txBox="1"/>
+          <p:nvPr/>
+        </p:nvSpPr>
+        <p:spPr>
+          <a:xfrm>
+            <a:off x="576000" y="5111998"/>
+            <a:ext cx="2520000" cy="575999"/>
+          </a:xfrm>
+          <a:prstGeom prst="rect">
+            <a:avLst/>
+          </a:prstGeom>
+          <a:noFill/>
+        </p:spPr>
+        <p:txBody>
+          <a:bodyPr wrap="square" anchor="ctr" tIns="7200" bIns="7200">
+            <a:spAutoFit/>
+          </a:bodyPr>
+          <a:lstStyle/>
+          <a:p>
+            <a:pPr algn="l"/>
+            <a:r>
+              <a:rPr sz="1800" b="1">
                 <a:solidFill>
                   <a:srgbClr val="003F72"/>
                 </a:solidFill>
                 <a:latin typeface="Arial"/>
               </a:rPr>
-              <a:t>Zeitrahmen:</a:t>
-            </a:r>
-          </a:p>
-        </p:txBody>
-      </p:sp>
-      <p:sp>
-        <p:nvSpPr>
-          <p:cNvPr id="29" name="TextBox 28"/>
-          <p:cNvSpPr txBox="1"/>
-          <p:nvPr/>
-        </p:nvSpPr>
-        <p:spPr>
-          <a:xfrm>
-            <a:off x="2015999" y="4370400"/>
-            <a:ext cx="9745200" cy="234000"/>
-          </a:xfrm>
-          <a:prstGeom prst="rect">
-            <a:avLst/>
-          </a:prstGeom>
-          <a:noFill/>
-        </p:spPr>
-        <p:txBody>
-          <a:bodyPr wrap="square">
-            <a:spAutoFit/>
-          </a:bodyPr>
-          <a:lstStyle/>
-          <a:p>
-            <a:pPr algn="l"/>
-            <a:r>
-              <a:rPr sz="1300" b="0" i="0">
+              <a:t>Zeitrahmen</a:t>
+            </a:r>
+          </a:p>
+        </p:txBody>
+      </p:sp>
+      <p:sp>
+        <p:nvSpPr>
+          <p:cNvPr id="32" name="TextBox 31"/>
+          <p:cNvSpPr txBox="1"/>
+          <p:nvPr/>
+        </p:nvSpPr>
+        <p:spPr>
+          <a:xfrm>
+            <a:off x="3240000" y="5111998"/>
+            <a:ext cx="8449200" cy="575999"/>
+          </a:xfrm>
+          <a:prstGeom prst="rect">
+            <a:avLst/>
+          </a:prstGeom>
+          <a:noFill/>
+        </p:spPr>
+        <p:txBody>
+          <a:bodyPr wrap="square" anchor="ctr" tIns="7200" bIns="7200">
+            <a:spAutoFit/>
+          </a:bodyPr>
+          <a:lstStyle/>
+          <a:p>
+            <a:pPr algn="l"/>
+            <a:r>
+              <a:rPr sz="1800" b="0">
                 <a:solidFill>
                   <a:srgbClr val="1C1C2E"/>
                 </a:solidFill>
                 <a:latin typeface="Arial"/>
               </a:rPr>
-              <a:t>40 Stunden  |  Bearbeitungszeitraum bis 30.04.2026</a:t>
+              <a:t>40 Stunden, Bearbeitungszeitraum bis 30.04.2026</a:t>
             </a:r>
           </a:p>
         </p:txBody>
@@ -17330,7 +17462,7 @@
             <a:r>
               <a:rPr sz="800" b="0">
                 <a:solidFill>
-                  <a:srgbClr val="6B7A90"/>
+                  <a:srgbClr val="FFFFFF"/>
                 </a:solidFill>
                 <a:latin typeface="Arial"/>
               </a:rPr>
@@ -17365,7 +17497,7 @@
             <a:r>
               <a:rPr sz="800" b="0">
                 <a:solidFill>
-                  <a:srgbClr val="6B7A90"/>
+                  <a:srgbClr val="FFFFFF"/>
                 </a:solidFill>
                 <a:latin typeface="Arial"/>
               </a:rPr>
@@ -17382,8 +17514,8 @@
         </p:nvSpPr>
         <p:spPr>
           <a:xfrm>
-            <a:off x="360000" y="1116000"/>
-            <a:ext cx="180000" cy="288000"/>
+            <a:off x="360000" y="1170000"/>
+            <a:ext cx="180000" cy="180000"/>
           </a:xfrm>
           <a:prstGeom prst="rect">
             <a:avLst/>
@@ -17935,8 +18067,8 @@
         </p:nvSpPr>
         <p:spPr>
           <a:xfrm>
-            <a:off x="6636600" y="1116000"/>
-            <a:ext cx="180000" cy="288000"/>
+            <a:off x="6636600" y="1170000"/>
+            <a:ext cx="180000" cy="180000"/>
           </a:xfrm>
           <a:prstGeom prst="rect">
             <a:avLst/>
@@ -18940,7 +19072,7 @@
             <a:r>
               <a:rPr sz="800" b="0" i="0">
                 <a:solidFill>
-                  <a:srgbClr val="6B7A90"/>
+                  <a:srgbClr val="FFFFFF"/>
                 </a:solidFill>
                 <a:latin typeface="Arial"/>
               </a:rPr>
@@ -18975,7 +19107,7 @@
             <a:r>
               <a:rPr sz="800" b="0" i="0">
                 <a:solidFill>
-                  <a:srgbClr val="6B7A90"/>
+                  <a:srgbClr val="FFFFFF"/>
                 </a:solidFill>
                 <a:latin typeface="Arial"/>
               </a:rPr>
@@ -20873,7 +21005,7 @@
             <a:avLst/>
           </a:prstGeom>
           <a:solidFill>
-            <a:srgbClr val="131325"/>
+            <a:srgbClr val="003F72"/>
           </a:solidFill>
           <a:ln>
             <a:noFill/>
@@ -20928,7 +21060,7 @@
             <a:r>
               <a:rPr sz="800" b="0">
                 <a:solidFill>
-                  <a:srgbClr val="6B7A90"/>
+                  <a:srgbClr val="FFFFFF"/>
                 </a:solidFill>
                 <a:latin typeface="Arial"/>
               </a:rPr>
@@ -20963,7 +21095,7 @@
             <a:r>
               <a:rPr sz="800" b="0">
                 <a:solidFill>
-                  <a:srgbClr val="6B7A90"/>
+                  <a:srgbClr val="FFFFFF"/>
                 </a:solidFill>
                 <a:latin typeface="Arial"/>
               </a:rPr>
@@ -23165,7 +23297,7 @@
             <a:avLst/>
           </a:prstGeom>
           <a:solidFill>
-            <a:srgbClr val="131325"/>
+            <a:srgbClr val="003F72"/>
           </a:solidFill>
           <a:ln>
             <a:noFill/>
@@ -23220,7 +23352,7 @@
             <a:r>
               <a:rPr sz="800" b="0">
                 <a:solidFill>
-                  <a:srgbClr val="6B7A90"/>
+                  <a:srgbClr val="FFFFFF"/>
                 </a:solidFill>
                 <a:latin typeface="Arial"/>
               </a:rPr>
@@ -23255,7 +23387,7 @@
             <a:r>
               <a:rPr sz="800" b="0">
                 <a:solidFill>
-                  <a:srgbClr val="6B7A90"/>
+                  <a:srgbClr val="FFFFFF"/>
                 </a:solidFill>
                 <a:latin typeface="Arial"/>
               </a:rPr>
@@ -25295,7 +25427,7 @@
             <a:r>
               <a:rPr sz="800" b="0" i="0">
                 <a:solidFill>
-                  <a:srgbClr val="6B7A90"/>
+                  <a:srgbClr val="FFFFFF"/>
                 </a:solidFill>
                 <a:latin typeface="Arial"/>
               </a:rPr>
@@ -25330,7 +25462,7 @@
             <a:r>
               <a:rPr sz="800" b="0" i="0">
                 <a:solidFill>
-                  <a:srgbClr val="6B7A90"/>
+                  <a:srgbClr val="FFFFFF"/>
                 </a:solidFill>
                 <a:latin typeface="Arial"/>
               </a:rPr>

</xml_diff>